<commit_message>
making variable and function names more consistent, updating math model Figure
</commit_message>
<xml_diff>
--- a/Figs/GemcitabinePaper_Figures.pptx
+++ b/Figs/GemcitabinePaper_Figures.pptx
@@ -264,7 +264,7 @@
           <a:p>
             <a:fld id="{FA5DAE86-69C4-0D4D-B54F-2D0B7B3FA500}" type="datetimeFigureOut">
               <a:rPr lang="en-US" smtClean="0"/>
-              <a:t>5/17/23</a:t>
+              <a:t>5/25/23</a:t>
             </a:fld>
             <a:endParaRPr lang="en-US"/>
           </a:p>
@@ -462,7 +462,7 @@
           <a:p>
             <a:fld id="{FA5DAE86-69C4-0D4D-B54F-2D0B7B3FA500}" type="datetimeFigureOut">
               <a:rPr lang="en-US" smtClean="0"/>
-              <a:t>5/17/23</a:t>
+              <a:t>5/25/23</a:t>
             </a:fld>
             <a:endParaRPr lang="en-US"/>
           </a:p>
@@ -670,7 +670,7 @@
           <a:p>
             <a:fld id="{FA5DAE86-69C4-0D4D-B54F-2D0B7B3FA500}" type="datetimeFigureOut">
               <a:rPr lang="en-US" smtClean="0"/>
-              <a:t>5/17/23</a:t>
+              <a:t>5/25/23</a:t>
             </a:fld>
             <a:endParaRPr lang="en-US"/>
           </a:p>
@@ -868,7 +868,7 @@
           <a:p>
             <a:fld id="{FA5DAE86-69C4-0D4D-B54F-2D0B7B3FA500}" type="datetimeFigureOut">
               <a:rPr lang="en-US" smtClean="0"/>
-              <a:t>5/17/23</a:t>
+              <a:t>5/25/23</a:t>
             </a:fld>
             <a:endParaRPr lang="en-US"/>
           </a:p>
@@ -1143,7 +1143,7 @@
           <a:p>
             <a:fld id="{FA5DAE86-69C4-0D4D-B54F-2D0B7B3FA500}" type="datetimeFigureOut">
               <a:rPr lang="en-US" smtClean="0"/>
-              <a:t>5/17/23</a:t>
+              <a:t>5/25/23</a:t>
             </a:fld>
             <a:endParaRPr lang="en-US"/>
           </a:p>
@@ -1408,7 +1408,7 @@
           <a:p>
             <a:fld id="{FA5DAE86-69C4-0D4D-B54F-2D0B7B3FA500}" type="datetimeFigureOut">
               <a:rPr lang="en-US" smtClean="0"/>
-              <a:t>5/17/23</a:t>
+              <a:t>5/25/23</a:t>
             </a:fld>
             <a:endParaRPr lang="en-US"/>
           </a:p>
@@ -1820,7 +1820,7 @@
           <a:p>
             <a:fld id="{FA5DAE86-69C4-0D4D-B54F-2D0B7B3FA500}" type="datetimeFigureOut">
               <a:rPr lang="en-US" smtClean="0"/>
-              <a:t>5/17/23</a:t>
+              <a:t>5/25/23</a:t>
             </a:fld>
             <a:endParaRPr lang="en-US"/>
           </a:p>
@@ -1961,7 +1961,7 @@
           <a:p>
             <a:fld id="{FA5DAE86-69C4-0D4D-B54F-2D0B7B3FA500}" type="datetimeFigureOut">
               <a:rPr lang="en-US" smtClean="0"/>
-              <a:t>5/17/23</a:t>
+              <a:t>5/25/23</a:t>
             </a:fld>
             <a:endParaRPr lang="en-US"/>
           </a:p>
@@ -2074,7 +2074,7 @@
           <a:p>
             <a:fld id="{FA5DAE86-69C4-0D4D-B54F-2D0B7B3FA500}" type="datetimeFigureOut">
               <a:rPr lang="en-US" smtClean="0"/>
-              <a:t>5/17/23</a:t>
+              <a:t>5/25/23</a:t>
             </a:fld>
             <a:endParaRPr lang="en-US"/>
           </a:p>
@@ -2385,7 +2385,7 @@
           <a:p>
             <a:fld id="{FA5DAE86-69C4-0D4D-B54F-2D0B7B3FA500}" type="datetimeFigureOut">
               <a:rPr lang="en-US" smtClean="0"/>
-              <a:t>5/17/23</a:t>
+              <a:t>5/25/23</a:t>
             </a:fld>
             <a:endParaRPr lang="en-US"/>
           </a:p>
@@ -2673,7 +2673,7 @@
           <a:p>
             <a:fld id="{FA5DAE86-69C4-0D4D-B54F-2D0B7B3FA500}" type="datetimeFigureOut">
               <a:rPr lang="en-US" smtClean="0"/>
-              <a:t>5/17/23</a:t>
+              <a:t>5/25/23</a:t>
             </a:fld>
             <a:endParaRPr lang="en-US"/>
           </a:p>
@@ -2914,7 +2914,7 @@
           <a:p>
             <a:fld id="{FA5DAE86-69C4-0D4D-B54F-2D0B7B3FA500}" type="datetimeFigureOut">
               <a:rPr lang="en-US" smtClean="0"/>
-              <a:t>5/17/23</a:t>
+              <a:t>5/25/23</a:t>
             </a:fld>
             <a:endParaRPr lang="en-US"/>
           </a:p>
@@ -3416,10 +3416,10 @@
       </p:grpSpPr>
       <p:pic>
         <p:nvPicPr>
-          <p:cNvPr id="7" name="Picture 6" descr="A picture containing line, diagram, plot, text&#10;&#10;Description automatically generated">
-            <a:extLst>
-              <a:ext uri="{FF2B5EF4-FFF2-40B4-BE49-F238E27FC236}">
-                <a16:creationId xmlns:a16="http://schemas.microsoft.com/office/drawing/2014/main" id="{51A85AAB-8E78-0D99-F691-62A3A2030E57}"/>
+          <p:cNvPr id="8" name="Picture 7" descr="A picture containing text, screenshot, diagram, number&#10;&#10;Description automatically generated">
+            <a:extLst>
+              <a:ext uri="{FF2B5EF4-FFF2-40B4-BE49-F238E27FC236}">
+                <a16:creationId xmlns:a16="http://schemas.microsoft.com/office/drawing/2014/main" id="{BAFC3FDD-FAF7-B56A-548C-244ACC7825D9}"/>
               </a:ext>
             </a:extLst>
           </p:cNvPr>
@@ -3428,15 +3428,16 @@
           </p:cNvPicPr>
           <p:nvPr/>
         </p:nvPicPr>
-        <p:blipFill rotWithShape="1">
+        <p:blipFill>
           <a:blip r:embed="rId2"/>
-          <a:srcRect/>
-          <a:stretch/>
+          <a:stretch>
+            <a:fillRect/>
+          </a:stretch>
         </p:blipFill>
         <p:spPr>
           <a:xfrm>
-            <a:off x="2888849" y="307012"/>
-            <a:ext cx="4657358" cy="2109207"/>
+            <a:off x="2830721" y="2548094"/>
+            <a:ext cx="4812185" cy="4269967"/>
           </a:xfrm>
           <a:prstGeom prst="rect">
             <a:avLst/>
@@ -3445,10 +3446,10 @@
       </p:pic>
       <p:pic>
         <p:nvPicPr>
-          <p:cNvPr id="13" name="Picture 12" descr="A picture containing text, diagram, line, parallel&#10;&#10;Description automatically generated">
-            <a:extLst>
-              <a:ext uri="{FF2B5EF4-FFF2-40B4-BE49-F238E27FC236}">
-                <a16:creationId xmlns:a16="http://schemas.microsoft.com/office/drawing/2014/main" id="{7FAE7665-8391-0F8B-6454-18126D0754C6}"/>
+          <p:cNvPr id="5" name="Picture 4" descr="A picture containing line, diagram, plot, text&#10;&#10;Description automatically generated">
+            <a:extLst>
+              <a:ext uri="{FF2B5EF4-FFF2-40B4-BE49-F238E27FC236}">
+                <a16:creationId xmlns:a16="http://schemas.microsoft.com/office/drawing/2014/main" id="{CCFEA96D-AAA7-6AF5-2049-4625C9DD7400}"/>
               </a:ext>
             </a:extLst>
           </p:cNvPr>
@@ -3465,8 +3466,8 @@
         </p:blipFill>
         <p:spPr>
           <a:xfrm>
-            <a:off x="2888849" y="2616849"/>
-            <a:ext cx="4657358" cy="4116022"/>
+            <a:off x="2940050" y="338883"/>
+            <a:ext cx="4702856" cy="2077335"/>
           </a:xfrm>
           <a:prstGeom prst="rect">
             <a:avLst/>

</xml_diff>

<commit_message>
display output of alpha function
</commit_message>
<xml_diff>
--- a/Figs/GemcitabinePaper_Figures.pptx
+++ b/Figs/GemcitabinePaper_Figures.pptx
@@ -264,7 +264,7 @@
           <a:p>
             <a:fld id="{FA5DAE86-69C4-0D4D-B54F-2D0B7B3FA500}" type="datetimeFigureOut">
               <a:rPr lang="en-US" smtClean="0"/>
-              <a:t>5/25/23</a:t>
+              <a:t>7/10/23</a:t>
             </a:fld>
             <a:endParaRPr lang="en-US"/>
           </a:p>
@@ -462,7 +462,7 @@
           <a:p>
             <a:fld id="{FA5DAE86-69C4-0D4D-B54F-2D0B7B3FA500}" type="datetimeFigureOut">
               <a:rPr lang="en-US" smtClean="0"/>
-              <a:t>5/25/23</a:t>
+              <a:t>7/10/23</a:t>
             </a:fld>
             <a:endParaRPr lang="en-US"/>
           </a:p>
@@ -670,7 +670,7 @@
           <a:p>
             <a:fld id="{FA5DAE86-69C4-0D4D-B54F-2D0B7B3FA500}" type="datetimeFigureOut">
               <a:rPr lang="en-US" smtClean="0"/>
-              <a:t>5/25/23</a:t>
+              <a:t>7/10/23</a:t>
             </a:fld>
             <a:endParaRPr lang="en-US"/>
           </a:p>
@@ -868,7 +868,7 @@
           <a:p>
             <a:fld id="{FA5DAE86-69C4-0D4D-B54F-2D0B7B3FA500}" type="datetimeFigureOut">
               <a:rPr lang="en-US" smtClean="0"/>
-              <a:t>5/25/23</a:t>
+              <a:t>7/10/23</a:t>
             </a:fld>
             <a:endParaRPr lang="en-US"/>
           </a:p>
@@ -1143,7 +1143,7 @@
           <a:p>
             <a:fld id="{FA5DAE86-69C4-0D4D-B54F-2D0B7B3FA500}" type="datetimeFigureOut">
               <a:rPr lang="en-US" smtClean="0"/>
-              <a:t>5/25/23</a:t>
+              <a:t>7/10/23</a:t>
             </a:fld>
             <a:endParaRPr lang="en-US"/>
           </a:p>
@@ -1408,7 +1408,7 @@
           <a:p>
             <a:fld id="{FA5DAE86-69C4-0D4D-B54F-2D0B7B3FA500}" type="datetimeFigureOut">
               <a:rPr lang="en-US" smtClean="0"/>
-              <a:t>5/25/23</a:t>
+              <a:t>7/10/23</a:t>
             </a:fld>
             <a:endParaRPr lang="en-US"/>
           </a:p>
@@ -1820,7 +1820,7 @@
           <a:p>
             <a:fld id="{FA5DAE86-69C4-0D4D-B54F-2D0B7B3FA500}" type="datetimeFigureOut">
               <a:rPr lang="en-US" smtClean="0"/>
-              <a:t>5/25/23</a:t>
+              <a:t>7/10/23</a:t>
             </a:fld>
             <a:endParaRPr lang="en-US"/>
           </a:p>
@@ -1961,7 +1961,7 @@
           <a:p>
             <a:fld id="{FA5DAE86-69C4-0D4D-B54F-2D0B7B3FA500}" type="datetimeFigureOut">
               <a:rPr lang="en-US" smtClean="0"/>
-              <a:t>5/25/23</a:t>
+              <a:t>7/10/23</a:t>
             </a:fld>
             <a:endParaRPr lang="en-US"/>
           </a:p>
@@ -2074,7 +2074,7 @@
           <a:p>
             <a:fld id="{FA5DAE86-69C4-0D4D-B54F-2D0B7B3FA500}" type="datetimeFigureOut">
               <a:rPr lang="en-US" smtClean="0"/>
-              <a:t>5/25/23</a:t>
+              <a:t>7/10/23</a:t>
             </a:fld>
             <a:endParaRPr lang="en-US"/>
           </a:p>
@@ -2385,7 +2385,7 @@
           <a:p>
             <a:fld id="{FA5DAE86-69C4-0D4D-B54F-2D0B7B3FA500}" type="datetimeFigureOut">
               <a:rPr lang="en-US" smtClean="0"/>
-              <a:t>5/25/23</a:t>
+              <a:t>7/10/23</a:t>
             </a:fld>
             <a:endParaRPr lang="en-US"/>
           </a:p>
@@ -2673,7 +2673,7 @@
           <a:p>
             <a:fld id="{FA5DAE86-69C4-0D4D-B54F-2D0B7B3FA500}" type="datetimeFigureOut">
               <a:rPr lang="en-US" smtClean="0"/>
-              <a:t>5/25/23</a:t>
+              <a:t>7/10/23</a:t>
             </a:fld>
             <a:endParaRPr lang="en-US"/>
           </a:p>
@@ -2914,7 +2914,7 @@
           <a:p>
             <a:fld id="{FA5DAE86-69C4-0D4D-B54F-2D0B7B3FA500}" type="datetimeFigureOut">
               <a:rPr lang="en-US" smtClean="0"/>
-              <a:t>5/25/23</a:t>
+              <a:t>7/10/23</a:t>
             </a:fld>
             <a:endParaRPr lang="en-US"/>
           </a:p>
@@ -3416,10 +3416,10 @@
       </p:grpSpPr>
       <p:pic>
         <p:nvPicPr>
-          <p:cNvPr id="8" name="Picture 7" descr="A picture containing text, screenshot, diagram, number&#10;&#10;Description automatically generated">
-            <a:extLst>
-              <a:ext uri="{FF2B5EF4-FFF2-40B4-BE49-F238E27FC236}">
-                <a16:creationId xmlns:a16="http://schemas.microsoft.com/office/drawing/2014/main" id="{BAFC3FDD-FAF7-B56A-548C-244ACC7825D9}"/>
+          <p:cNvPr id="3" name="Picture 2" descr="A comparison of a number of numbers and a number of numbers&#10;&#10;Description automatically generated">
+            <a:extLst>
+              <a:ext uri="{FF2B5EF4-FFF2-40B4-BE49-F238E27FC236}">
+                <a16:creationId xmlns:a16="http://schemas.microsoft.com/office/drawing/2014/main" id="{C2D046C7-130A-7CE8-0C39-79219346317E}"/>
               </a:ext>
             </a:extLst>
           </p:cNvPr>
@@ -3436,8 +3436,37 @@
         </p:blipFill>
         <p:spPr>
           <a:xfrm>
-            <a:off x="2830721" y="2548094"/>
-            <a:ext cx="4812185" cy="4269967"/>
+            <a:off x="2830721" y="2530299"/>
+            <a:ext cx="4812185" cy="2111275"/>
+          </a:xfrm>
+          <a:prstGeom prst="rect">
+            <a:avLst/>
+          </a:prstGeom>
+        </p:spPr>
+      </p:pic>
+      <p:pic>
+        <p:nvPicPr>
+          <p:cNvPr id="8" name="Picture 7" descr="A picture containing text, screenshot, diagram, number&#10;&#10;Description automatically generated">
+            <a:extLst>
+              <a:ext uri="{FF2B5EF4-FFF2-40B4-BE49-F238E27FC236}">
+                <a16:creationId xmlns:a16="http://schemas.microsoft.com/office/drawing/2014/main" id="{BAFC3FDD-FAF7-B56A-548C-244ACC7825D9}"/>
+              </a:ext>
+            </a:extLst>
+          </p:cNvPr>
+          <p:cNvPicPr>
+            <a:picLocks noChangeAspect="1"/>
+          </p:cNvPicPr>
+          <p:nvPr/>
+        </p:nvPicPr>
+        <p:blipFill rotWithShape="1">
+          <a:blip r:embed="rId3"/>
+          <a:srcRect t="49028"/>
+          <a:stretch/>
+        </p:blipFill>
+        <p:spPr>
+          <a:xfrm>
+            <a:off x="2830721" y="4641574"/>
+            <a:ext cx="4812185" cy="2176487"/>
           </a:xfrm>
           <a:prstGeom prst="rect">
             <a:avLst/>
@@ -3459,7 +3488,7 @@
           <p:nvPr/>
         </p:nvPicPr>
         <p:blipFill>
-          <a:blip r:embed="rId3"/>
+          <a:blip r:embed="rId4"/>
           <a:stretch>
             <a:fillRect/>
           </a:stretch>

</xml_diff>